<commit_message>
Deck: layout fixes after Apple-style restyle
Co-Authored-By: Claude Sonnet 5.5 <noreply@anthropic.com>
Claude-Session: https://claude.ai/code/session_017w9Wz8TNpiESdat1g61ZHB
</commit_message>
<xml_diff>
--- a/submission/REDRED_2차_발표자료.pptx
+++ b/submission/REDRED_2차_발표자료.pptx
@@ -4645,11 +4645,11 @@
         <p:spPr>
           <a:xfrm>
             <a:off x="6583680" y="4389120"/>
-            <a:ext cx="5029200" cy="1005840"/>
+            <a:ext cx="5029200" cy="1188720"/>
           </a:xfrm>
           <a:prstGeom prst="roundRect">
             <a:avLst>
-              <a:gd name="adj" fmla="val 10909"/>
+              <a:gd name="adj" fmla="val 9231"/>
             </a:avLst>
           </a:prstGeom>
           <a:solidFill>
@@ -4711,7 +4711,7 @@
         <p:spPr>
           <a:xfrm>
             <a:off x="6766560" y="4937760"/>
-            <a:ext cx="4663440" cy="320040"/>
+            <a:ext cx="4663440" cy="502920"/>
           </a:xfrm>
           <a:prstGeom prst="rect">
             <a:avLst/>
@@ -4766,8 +4766,8 @@
         </p:nvSpPr>
         <p:spPr>
           <a:xfrm>
-            <a:off x="548640" y="5486400"/>
-            <a:ext cx="11064240" cy="822960"/>
+            <a:off x="548640" y="5715000"/>
+            <a:ext cx="11064240" cy="640080"/>
           </a:xfrm>
           <a:prstGeom prst="rect">
             <a:avLst/>
@@ -4783,7 +4783,7 @@
               <a:buNone/>
             </a:pPr>
             <a:r>
-              <a:rPr lang="en-US" sz="1400" dirty="0">
+              <a:rPr lang="en-US" sz="1300" dirty="0">
                 <a:solidFill>
                   <a:srgbClr val="7A7A7A"/>
                 </a:solidFill>
@@ -4793,7 +4793,7 @@
               </a:rPr>
               <a:t>C64·C256 = 쓰기 캐시 64·256항목. 원리: 행(y)마다 클록 게이트를 두어 쓰는 행의 128개 FF만 클록을 받는다(리셋 때만 전 행). 쓰기 캐시(64항목)는 전력 −16%, 면적 +5.5%로 이득이 작아 필수로 두지 않았다. 256항목은 오히려 전력이 늘었다.</a:t>
             </a:r>
-            <a:endParaRPr lang="en-US" sz="1400" dirty="0"/>
+            <a:endParaRPr lang="en-US" sz="1300" dirty="0"/>
           </a:p>
         </p:txBody>
       </p:sp>
@@ -7633,7 +7633,7 @@
                 <a:ea typeface="Malgun Gothic" pitchFamily="34" charset="-122"/>
                 <a:cs typeface="Malgun Gothic" pitchFamily="34" charset="-120"/>
               </a:rPr>
-              <a:t>P&amp;R 셀 배치도 (메모리 FF = 주황, 클록 게이트 = 빨강)</a:t>
+              <a:t>P&amp;R 셀 배치도 (플립플롭 = 연회색, 클록 게이트 = 파랑)</a:t>
             </a:r>
             <a:endParaRPr lang="en-US" sz="1100" dirty="0"/>
           </a:p>
@@ -9701,7 +9701,7 @@
         <p:spPr>
           <a:xfrm>
             <a:off x="548640" y="4114800"/>
-            <a:ext cx="5852160" cy="2395728"/>
+            <a:ext cx="5486400" cy="2240280"/>
           </a:xfrm>
           <a:prstGeom prst="rect">
             <a:avLst/>

</xml_diff>

<commit_message>
Bio-mimic candidates 2 (sparse rows) and 3 (forgetting) rejected by pre-registered criteria (§222)
Co-Authored-By: Claude Sonnet 5.5 <noreply@anthropic.com>
Claude-Session: https://claude.ai/code/session_017w9Wz8TNpiESdat1g61ZHB
</commit_message>
<xml_diff>
--- a/submission/REDRED_2차_발표자료.pptx
+++ b/submission/REDRED_2차_발표자료.pptx
@@ -10663,7 +10663,7 @@
                 <a:gridCol w="1188720"/>
                 <a:gridCol w="5852160"/>
               </a:tblGrid>
-              <a:tr h="493776">
+              <a:tr h="420624">
                 <a:tc>
                   <a:txBody>
                     <a:bodyPr/>
@@ -10673,7 +10673,7 @@
                         <a:buNone/>
                       </a:pPr>
                       <a:r>
-                        <a:rPr lang="en-US" sz="1300" dirty="0">
+                        <a:rPr lang="en-US" sz="1200" dirty="0">
                           <a:solidFill>
                             <a:srgbClr val="1D1D1F"/>
                           </a:solidFill>
@@ -10683,7 +10683,7 @@
                         </a:rPr>
                         <a:t>생체 모방 아이디어</a:t>
                       </a:r>
-                      <a:endParaRPr lang="en-US" sz="1300" dirty="0">
+                      <a:endParaRPr lang="en-US" sz="1200" dirty="0">
                         <a:latin typeface="나눔스퀘어 네오 Regular" charset="0"/>
                         <a:ea typeface="나눔스퀘어 네오 Regular" charset="0"/>
                         <a:cs typeface="나눔스퀘어 네오 Regular" charset="0"/>
@@ -10741,7 +10741,7 @@
                         <a:buNone/>
                       </a:pPr>
                       <a:r>
-                        <a:rPr lang="en-US" sz="1300" dirty="0">
+                        <a:rPr lang="en-US" sz="1200" dirty="0">
                           <a:solidFill>
                             <a:srgbClr val="1D1D1F"/>
                           </a:solidFill>
@@ -10751,7 +10751,7 @@
                         </a:rPr>
                         <a:t>결과</a:t>
                       </a:r>
-                      <a:endParaRPr lang="en-US" sz="1300" dirty="0">
+                      <a:endParaRPr lang="en-US" sz="1200" dirty="0">
                         <a:latin typeface="나눔스퀘어 네오 Regular" charset="0"/>
                         <a:ea typeface="나눔스퀘어 네오 Regular" charset="0"/>
                         <a:cs typeface="나눔스퀘어 네오 Regular" charset="0"/>
@@ -10809,7 +10809,7 @@
                         <a:buNone/>
                       </a:pPr>
                       <a:r>
-                        <a:rPr lang="en-US" sz="1300" dirty="0">
+                        <a:rPr lang="en-US" sz="1200" dirty="0">
                           <a:solidFill>
                             <a:srgbClr val="1D1D1F"/>
                           </a:solidFill>
@@ -10819,7 +10819,7 @@
                         </a:rPr>
                         <a:t>근거</a:t>
                       </a:r>
-                      <a:endParaRPr lang="en-US" sz="1300" dirty="0">
+                      <a:endParaRPr lang="en-US" sz="1200" dirty="0">
                         <a:latin typeface="나눔스퀘어 네오 Regular" charset="0"/>
                         <a:ea typeface="나눔스퀘어 네오 Regular" charset="0"/>
                         <a:cs typeface="나눔스퀘어 네오 Regular" charset="0"/>
@@ -10869,7 +10869,7 @@
                   </a:tcPr>
                 </a:tc>
               </a:tr>
-              <a:tr h="493776">
+              <a:tr h="420624">
                 <a:tc>
                   <a:txBody>
                     <a:bodyPr/>
@@ -10879,7 +10879,7 @@
                         <a:buNone/>
                       </a:pPr>
                       <a:r>
-                        <a:rPr lang="en-US" sz="1300" dirty="0">
+                        <a:rPr lang="en-US" sz="1200" dirty="0">
                           <a:solidFill>
                             <a:srgbClr val="1D1D1F"/>
                           </a:solidFill>
@@ -10889,7 +10889,7 @@
                         </a:rPr>
                         <a:t>중심와(fovea) / 이벤트 클러스터링 (1차)</a:t>
                       </a:r>
-                      <a:endParaRPr lang="en-US" sz="1300" dirty="0">
+                      <a:endParaRPr lang="en-US" sz="1200" dirty="0">
                         <a:latin typeface="나눔스퀘어 네오 Regular" charset="0"/>
                         <a:ea typeface="나눔스퀘어 네오 Regular" charset="0"/>
                         <a:cs typeface="나눔스퀘어 네오 Regular" charset="0"/>
@@ -10947,7 +10947,7 @@
                         <a:buNone/>
                       </a:pPr>
                       <a:r>
-                        <a:rPr lang="en-US" sz="1300" dirty="0">
+                        <a:rPr lang="en-US" sz="1200" dirty="0">
                           <a:solidFill>
                             <a:srgbClr val="0066CC"/>
                           </a:solidFill>
@@ -10957,7 +10957,7 @@
                         </a:rPr>
                         <a:t>채택</a:t>
                       </a:r>
-                      <a:endParaRPr lang="en-US" sz="1300" dirty="0">
+                      <a:endParaRPr lang="en-US" sz="1200" dirty="0">
                         <a:latin typeface="나눔스퀘어 네오 Regular" charset="0"/>
                         <a:ea typeface="나눔스퀘어 네오 Regular" charset="0"/>
                         <a:cs typeface="나눔스퀘어 네오 Regular" charset="0"/>
@@ -11015,7 +11015,7 @@
                         <a:buNone/>
                       </a:pPr>
                       <a:r>
-                        <a:rPr lang="en-US" sz="1300" dirty="0">
+                        <a:rPr lang="en-US" sz="1200" dirty="0">
                           <a:solidFill>
                             <a:srgbClr val="1D1D1F"/>
                           </a:solidFill>
@@ -11025,7 +11025,7 @@
                         </a:rPr>
                         <a:t>열 비트맵: 손실 57.6% → 6.9%(동일 합성 트래픽), 최종 결합판 0.47%(UZH 실측)</a:t>
                       </a:r>
-                      <a:endParaRPr lang="en-US" sz="1300" dirty="0">
+                      <a:endParaRPr lang="en-US" sz="1200" dirty="0">
                         <a:latin typeface="나눔스퀘어 네오 Regular" charset="0"/>
                         <a:ea typeface="나눔스퀘어 네오 Regular" charset="0"/>
                         <a:cs typeface="나눔스퀘어 네오 Regular" charset="0"/>
@@ -11075,7 +11075,7 @@
                   </a:tcPr>
                 </a:tc>
               </a:tr>
-              <a:tr h="493776">
+              <a:tr h="420624">
                 <a:tc>
                   <a:txBody>
                     <a:bodyPr/>
@@ -11085,7 +11085,7 @@
                         <a:buNone/>
                       </a:pPr>
                       <a:r>
-                        <a:rPr lang="en-US" sz="1300" dirty="0">
+                        <a:rPr lang="en-US" sz="1200" dirty="0">
                           <a:solidFill>
                             <a:srgbClr val="1D1D1F"/>
                           </a:solidFill>
@@ -11095,7 +11095,7 @@
                         </a:rPr>
                         <a:t>눈 깜빡임: 유휴 시 코어 클록 차단</a:t>
                       </a:r>
-                      <a:endParaRPr lang="en-US" sz="1300" dirty="0">
+                      <a:endParaRPr lang="en-US" sz="1200" dirty="0">
                         <a:latin typeface="나눔스퀘어 네오 Regular" charset="0"/>
                         <a:ea typeface="나눔스퀘어 네오 Regular" charset="0"/>
                         <a:cs typeface="나눔스퀘어 네오 Regular" charset="0"/>
@@ -11153,7 +11153,7 @@
                         <a:buNone/>
                       </a:pPr>
                       <a:r>
-                        <a:rPr lang="en-US" sz="1300" dirty="0">
+                        <a:rPr lang="en-US" sz="1200" dirty="0">
                           <a:solidFill>
                             <a:srgbClr val="0066CC"/>
                           </a:solidFill>
@@ -11163,7 +11163,7 @@
                         </a:rPr>
                         <a:t>채택</a:t>
                       </a:r>
-                      <a:endParaRPr lang="en-US" sz="1300" dirty="0">
+                      <a:endParaRPr lang="en-US" sz="1200" dirty="0">
                         <a:latin typeface="나눔스퀘어 네오 Regular" charset="0"/>
                         <a:ea typeface="나눔스퀘어 네오 Regular" charset="0"/>
                         <a:cs typeface="나눔스퀘어 네오 Regular" charset="0"/>
@@ -11221,7 +11221,7 @@
                         <a:buNone/>
                       </a:pPr>
                       <a:r>
-                        <a:rPr lang="en-US" sz="1300" dirty="0">
+                        <a:rPr lang="en-US" sz="1200" dirty="0">
                           <a:solidFill>
                             <a:srgbClr val="1D1D1F"/>
                           </a:solidFill>
@@ -11231,7 +11231,7 @@
                         </a:rPr>
                         <a:t>항상-켬과 출력·메모리 일치, 유휴 전력 −71%(시험 입력)</a:t>
                       </a:r>
-                      <a:endParaRPr lang="en-US" sz="1300" dirty="0">
+                      <a:endParaRPr lang="en-US" sz="1200" dirty="0">
                         <a:latin typeface="나눔스퀘어 네오 Regular" charset="0"/>
                         <a:ea typeface="나눔스퀘어 네오 Regular" charset="0"/>
                         <a:cs typeface="나눔스퀘어 네오 Regular" charset="0"/>
@@ -11281,7 +11281,7 @@
                   </a:tcPr>
                 </a:tc>
               </a:tr>
-              <a:tr h="493776">
+              <a:tr h="420624">
                 <a:tc>
                   <a:txBody>
                     <a:bodyPr/>
@@ -11291,7 +11291,7 @@
                         <a:buNone/>
                       </a:pPr>
                       <a:r>
-                        <a:rPr lang="en-US" sz="1300" dirty="0">
+                        <a:rPr lang="en-US" sz="1200" dirty="0">
                           <a:solidFill>
                             <a:srgbClr val="1D1D1F"/>
                           </a:solidFill>
@@ -11301,7 +11301,7 @@
                         </a:rPr>
                         <a:t>행 단위 선택적 활성화 (메모리)</a:t>
                       </a:r>
-                      <a:endParaRPr lang="en-US" sz="1300" dirty="0">
+                      <a:endParaRPr lang="en-US" sz="1200" dirty="0">
                         <a:latin typeface="나눔스퀘어 네오 Regular" charset="0"/>
                         <a:ea typeface="나눔스퀘어 네오 Regular" charset="0"/>
                         <a:cs typeface="나눔스퀘어 네오 Regular" charset="0"/>
@@ -11359,7 +11359,7 @@
                         <a:buNone/>
                       </a:pPr>
                       <a:r>
-                        <a:rPr lang="en-US" sz="1300" dirty="0">
+                        <a:rPr lang="en-US" sz="1200" dirty="0">
                           <a:solidFill>
                             <a:srgbClr val="0066CC"/>
                           </a:solidFill>
@@ -11369,7 +11369,7 @@
                         </a:rPr>
                         <a:t>채택</a:t>
                       </a:r>
-                      <a:endParaRPr lang="en-US" sz="1300" dirty="0">
+                      <a:endParaRPr lang="en-US" sz="1200" dirty="0">
                         <a:latin typeface="나눔스퀘어 네오 Regular" charset="0"/>
                         <a:ea typeface="나눔스퀘어 네오 Regular" charset="0"/>
                         <a:cs typeface="나눔스퀘어 네오 Regular" charset="0"/>
@@ -11427,7 +11427,7 @@
                         <a:buNone/>
                       </a:pPr>
                       <a:r>
-                        <a:rPr lang="en-US" sz="1300" dirty="0">
+                        <a:rPr lang="en-US" sz="1200" dirty="0">
                           <a:solidFill>
                             <a:srgbClr val="1D1D1F"/>
                           </a:solidFill>
@@ -11437,7 +11437,7 @@
                         </a:rPr>
                         <a:t>전력 −65.5%, 면적 −5%</a:t>
                       </a:r>
-                      <a:endParaRPr lang="en-US" sz="1300" dirty="0">
+                      <a:endParaRPr lang="en-US" sz="1200" dirty="0">
                         <a:latin typeface="나눔스퀘어 네오 Regular" charset="0"/>
                         <a:ea typeface="나눔스퀘어 네오 Regular" charset="0"/>
                         <a:cs typeface="나눔스퀘어 네오 Regular" charset="0"/>
@@ -11487,7 +11487,7 @@
                   </a:tcPr>
                 </a:tc>
               </a:tr>
-              <a:tr h="493776">
+              <a:tr h="420624">
                 <a:tc>
                   <a:txBody>
                     <a:bodyPr/>
@@ -11497,7 +11497,7 @@
                         <a:buNone/>
                       </a:pPr>
                       <a:r>
-                        <a:rPr lang="en-US" sz="1300" dirty="0">
+                        <a:rPr lang="en-US" sz="1200" dirty="0">
                           <a:solidFill>
                             <a:srgbClr val="1D1D1F"/>
                           </a:solidFill>
@@ -11507,7 +11507,7 @@
                         </a:rPr>
                         <a:t>이득 조절(과부하 솎아내기)</a:t>
                       </a:r>
-                      <a:endParaRPr lang="en-US" sz="1300" dirty="0">
+                      <a:endParaRPr lang="en-US" sz="1200" dirty="0">
                         <a:latin typeface="나눔스퀘어 네오 Regular" charset="0"/>
                         <a:ea typeface="나눔스퀘어 네오 Regular" charset="0"/>
                         <a:cs typeface="나눔스퀘어 네오 Regular" charset="0"/>
@@ -11565,7 +11565,7 @@
                         <a:buNone/>
                       </a:pPr>
                       <a:r>
-                        <a:rPr lang="en-US" sz="1300" dirty="0">
+                        <a:rPr lang="en-US" sz="1200" dirty="0">
                           <a:solidFill>
                             <a:srgbClr val="1D1D1F"/>
                           </a:solidFill>
@@ -11575,7 +11575,7 @@
                         </a:rPr>
                         <a:t>기각·정정</a:t>
                       </a:r>
-                      <a:endParaRPr lang="en-US" sz="1300" dirty="0">
+                      <a:endParaRPr lang="en-US" sz="1200" dirty="0">
                         <a:latin typeface="나눔스퀘어 네오 Regular" charset="0"/>
                         <a:ea typeface="나눔스퀘어 네오 Regular" charset="0"/>
                         <a:cs typeface="나눔스퀘어 네오 Regular" charset="0"/>
@@ -11633,7 +11633,7 @@
                         <a:buNone/>
                       </a:pPr>
                       <a:r>
-                        <a:rPr lang="en-US" sz="1300" dirty="0">
+                        <a:rPr lang="en-US" sz="1200" dirty="0">
                           <a:solidFill>
                             <a:srgbClr val="1D1D1F"/>
                           </a:solidFill>
@@ -11643,7 +11643,7 @@
                         </a:rPr>
                         <a:t>합성 장면에서만 이득, 실제 DELTA 프레임에서 이득 없음</a:t>
                       </a:r>
-                      <a:endParaRPr lang="en-US" sz="1300" dirty="0">
+                      <a:endParaRPr lang="en-US" sz="1200" dirty="0">
                         <a:latin typeface="나눔스퀘어 네오 Regular" charset="0"/>
                         <a:ea typeface="나눔스퀘어 네오 Regular" charset="0"/>
                         <a:cs typeface="나눔스퀘어 네오 Regular" charset="0"/>
@@ -11693,7 +11693,7 @@
                   </a:tcPr>
                 </a:tc>
               </a:tr>
-              <a:tr h="493776">
+              <a:tr h="420624">
                 <a:tc>
                   <a:txBody>
                     <a:bodyPr/>
@@ -11703,7 +11703,7 @@
                         <a:buNone/>
                       </a:pPr>
                       <a:r>
-                        <a:rPr lang="en-US" sz="1300" dirty="0">
+                        <a:rPr lang="en-US" sz="1200" dirty="0">
                           <a:solidFill>
                             <a:srgbClr val="1D1D1F"/>
                           </a:solidFill>
@@ -11713,7 +11713,7 @@
                         </a:rPr>
                         <a:t>추정기 입력 줄이기(ON만/중심 가중/불응기)</a:t>
                       </a:r>
-                      <a:endParaRPr lang="en-US" sz="1300" dirty="0">
+                      <a:endParaRPr lang="en-US" sz="1200" dirty="0">
                         <a:latin typeface="나눔스퀘어 네오 Regular" charset="0"/>
                         <a:ea typeface="나눔스퀘어 네오 Regular" charset="0"/>
                         <a:cs typeface="나눔스퀘어 네오 Regular" charset="0"/>
@@ -11771,7 +11771,7 @@
                         <a:buNone/>
                       </a:pPr>
                       <a:r>
-                        <a:rPr lang="en-US" sz="1300" dirty="0">
+                        <a:rPr lang="en-US" sz="1200" dirty="0">
                           <a:solidFill>
                             <a:srgbClr val="1D1D1F"/>
                           </a:solidFill>
@@ -11781,7 +11781,7 @@
                         </a:rPr>
                         <a:t>기각</a:t>
                       </a:r>
-                      <a:endParaRPr lang="en-US" sz="1300" dirty="0">
+                      <a:endParaRPr lang="en-US" sz="1200" dirty="0">
                         <a:latin typeface="나눔스퀘어 네오 Regular" charset="0"/>
                         <a:ea typeface="나눔스퀘어 네오 Regular" charset="0"/>
                         <a:cs typeface="나눔스퀘어 네오 Regular" charset="0"/>
@@ -11839,7 +11839,7 @@
                         <a:buNone/>
                       </a:pPr>
                       <a:r>
-                        <a:rPr lang="en-US" sz="1300" dirty="0">
+                        <a:rPr lang="en-US" sz="1200" dirty="0">
                           <a:solidFill>
                             <a:srgbClr val="1D1D1F"/>
                           </a:solidFill>
@@ -11849,7 +11849,7 @@
                         </a:rPr>
                         <a:t>정확도 1.5배 이상 악화</a:t>
                       </a:r>
-                      <a:endParaRPr lang="en-US" sz="1300" dirty="0">
+                      <a:endParaRPr lang="en-US" sz="1200" dirty="0">
                         <a:latin typeface="나눔스퀘어 네오 Regular" charset="0"/>
                         <a:ea typeface="나눔스퀘어 네오 Regular" charset="0"/>
                         <a:cs typeface="나눔스퀘어 네오 Regular" charset="0"/>
@@ -11899,7 +11899,7 @@
                   </a:tcPr>
                 </a:tc>
               </a:tr>
-              <a:tr h="493776">
+              <a:tr h="420624">
                 <a:tc>
                   <a:txBody>
                     <a:bodyPr/>
@@ -11909,7 +11909,7 @@
                         <a:buNone/>
                       </a:pPr>
                       <a:r>
-                        <a:rPr lang="en-US" sz="1300" dirty="0">
+                        <a:rPr lang="en-US" sz="1200" dirty="0">
                           <a:solidFill>
                             <a:srgbClr val="1D1D1F"/>
                           </a:solidFill>
@@ -11919,7 +11919,7 @@
                         </a:rPr>
                         <a:t>미세 안구운동(지터)</a:t>
                       </a:r>
-                      <a:endParaRPr lang="en-US" sz="1300" dirty="0">
+                      <a:endParaRPr lang="en-US" sz="1200" dirty="0">
                         <a:latin typeface="나눔스퀘어 네오 Regular" charset="0"/>
                         <a:ea typeface="나눔스퀘어 네오 Regular" charset="0"/>
                         <a:cs typeface="나눔스퀘어 네오 Regular" charset="0"/>
@@ -11977,7 +11977,7 @@
                         <a:buNone/>
                       </a:pPr>
                       <a:r>
-                        <a:rPr lang="en-US" sz="1300" dirty="0">
+                        <a:rPr lang="en-US" sz="1200" dirty="0">
                           <a:solidFill>
                             <a:srgbClr val="1D1D1F"/>
                           </a:solidFill>
@@ -11987,7 +11987,7 @@
                         </a:rPr>
                         <a:t>기각</a:t>
                       </a:r>
-                      <a:endParaRPr lang="en-US" sz="1300" dirty="0">
+                      <a:endParaRPr lang="en-US" sz="1200" dirty="0">
                         <a:latin typeface="나눔스퀘어 네오 Regular" charset="0"/>
                         <a:ea typeface="나눔스퀘어 네오 Regular" charset="0"/>
                         <a:cs typeface="나눔스퀘어 네오 Regular" charset="0"/>
@@ -12045,7 +12045,7 @@
                         <a:buNone/>
                       </a:pPr>
                       <a:r>
-                        <a:rPr lang="en-US" sz="1300" dirty="0">
+                        <a:rPr lang="en-US" sz="1200" dirty="0">
                           <a:solidFill>
                             <a:srgbClr val="1D1D1F"/>
                           </a:solidFill>
@@ -12055,7 +12055,7 @@
                         </a:rPr>
                         <a:t>부화소 복원 효과 없음</a:t>
                       </a:r>
-                      <a:endParaRPr lang="en-US" sz="1300" dirty="0">
+                      <a:endParaRPr lang="en-US" sz="1200" dirty="0">
                         <a:latin typeface="나눔스퀘어 네오 Regular" charset="0"/>
                         <a:ea typeface="나눔스퀘어 네오 Regular" charset="0"/>
                         <a:cs typeface="나눔스퀘어 네오 Regular" charset="0"/>
@@ -12105,7 +12105,7 @@
                   </a:tcPr>
                 </a:tc>
               </a:tr>
-              <a:tr h="493776">
+              <a:tr h="420624">
                 <a:tc>
                   <a:txBody>
                     <a:bodyPr/>
@@ -12115,7 +12115,7 @@
                         <a:buNone/>
                       </a:pPr>
                       <a:r>
-                        <a:rPr lang="en-US" sz="1300" dirty="0">
+                        <a:rPr lang="en-US" sz="1200" dirty="0">
                           <a:solidFill>
                             <a:srgbClr val="1D1D1F"/>
                           </a:solidFill>
@@ -12125,7 +12125,7 @@
                         </a:rPr>
                         <a:t>원심성 복사(VOR): 회전 지령을 θ 사전분포로</a:t>
                       </a:r>
-                      <a:endParaRPr lang="en-US" sz="1300" dirty="0">
+                      <a:endParaRPr lang="en-US" sz="1200" dirty="0">
                         <a:latin typeface="나눔스퀘어 네오 Regular" charset="0"/>
                         <a:ea typeface="나눔스퀘어 네오 Regular" charset="0"/>
                         <a:cs typeface="나눔스퀘어 네오 Regular" charset="0"/>
@@ -12183,7 +12183,7 @@
                         <a:buNone/>
                       </a:pPr>
                       <a:r>
-                        <a:rPr lang="en-US" sz="1300" dirty="0">
+                        <a:rPr lang="en-US" sz="1200" dirty="0">
                           <a:solidFill>
                             <a:srgbClr val="1D1D1F"/>
                           </a:solidFill>
@@ -12193,7 +12193,7 @@
                         </a:rPr>
                         <a:t>기각</a:t>
                       </a:r>
-                      <a:endParaRPr lang="en-US" sz="1300" dirty="0">
+                      <a:endParaRPr lang="en-US" sz="1200" dirty="0">
                         <a:latin typeface="나눔스퀘어 네오 Regular" charset="0"/>
                         <a:ea typeface="나눔스퀘어 네오 Regular" charset="0"/>
                         <a:cs typeface="나눔스퀘어 네오 Regular" charset="0"/>
@@ -12251,7 +12251,7 @@
                         <a:buNone/>
                       </a:pPr>
                       <a:r>
-                        <a:rPr lang="en-US" sz="1300" dirty="0">
+                        <a:rPr lang="en-US" sz="1200" dirty="0">
                           <a:solidFill>
                             <a:srgbClr val="1D1D1F"/>
                           </a:solidFill>
@@ -12261,7 +12261,7 @@
                         </a:rPr>
                         <a:t>UZH 평균 23.4°→8.5°이나 RobotEvt 36.1°→34.9°(기준 25.3° 미달), 사전 등록 기준 미통과</a:t>
                       </a:r>
-                      <a:endParaRPr lang="en-US" sz="1300" dirty="0">
+                      <a:endParaRPr lang="en-US" sz="1200" dirty="0">
                         <a:latin typeface="나눔스퀘어 네오 Regular" charset="0"/>
                         <a:ea typeface="나눔스퀘어 네오 Regular" charset="0"/>
                         <a:cs typeface="나눔스퀘어 네오 Regular" charset="0"/>
@@ -12311,7 +12311,7 @@
                   </a:tcPr>
                 </a:tc>
               </a:tr>
-              <a:tr h="493776">
+              <a:tr h="420624">
                 <a:tc>
                   <a:txBody>
                     <a:bodyPr/>
@@ -12321,7 +12321,7 @@
                         <a:buNone/>
                       </a:pPr>
                       <a:r>
-                        <a:rPr lang="en-US" sz="1300" dirty="0">
+                        <a:rPr lang="en-US" sz="1200" dirty="0">
                           <a:solidFill>
                             <a:srgbClr val="1D1D1F"/>
                           </a:solidFill>
@@ -12329,9 +12329,9 @@
                           <a:ea typeface="나눔스퀘어 네오 Regular" pitchFamily="34" charset="-122"/>
                           <a:cs typeface="나눔스퀘어 네오 Regular" pitchFamily="34" charset="-120"/>
                         </a:rPr>
-                        <a:t>최근 쓰기 캐시 (감각 기억)</a:t>
+                        <a:t>희소 행 할당(해마식 지연 할당)</a:t>
                       </a:r>
-                      <a:endParaRPr lang="en-US" sz="1300" dirty="0">
+                      <a:endParaRPr lang="en-US" sz="1200" dirty="0">
                         <a:latin typeface="나눔스퀘어 네오 Regular" charset="0"/>
                         <a:ea typeface="나눔스퀘어 네오 Regular" charset="0"/>
                         <a:cs typeface="나눔스퀘어 네오 Regular" charset="0"/>
@@ -12389,17 +12389,17 @@
                         <a:buNone/>
                       </a:pPr>
                       <a:r>
-                        <a:rPr lang="en-US" sz="1300" dirty="0">
+                        <a:rPr lang="en-US" sz="1200" dirty="0">
                           <a:solidFill>
-                            <a:srgbClr val="7A7A7A"/>
+                            <a:srgbClr val="1D1D1F"/>
                           </a:solidFill>
                           <a:latin typeface="나눔스퀘어 네오 Bold" pitchFamily="34" charset="0"/>
                           <a:ea typeface="나눔스퀘어 네오 Bold" pitchFamily="34" charset="-122"/>
                           <a:cs typeface="나눔스퀘어 네오 Bold" pitchFamily="34" charset="-120"/>
                         </a:rPr>
-                        <a:t>보류</a:t>
+                        <a:t>기각</a:t>
                       </a:r>
-                      <a:endParaRPr lang="en-US" sz="1300" dirty="0">
+                      <a:endParaRPr lang="en-US" sz="1200" dirty="0">
                         <a:latin typeface="나눔스퀘어 네오 Regular" charset="0"/>
                         <a:ea typeface="나눔스퀘어 네오 Regular" charset="0"/>
                         <a:cs typeface="나눔스퀘어 네오 Regular" charset="0"/>
@@ -12457,7 +12457,419 @@
                         <a:buNone/>
                       </a:pPr>
                       <a:r>
-                        <a:rPr lang="en-US" sz="1300" dirty="0">
+                        <a:rPr lang="en-US" sz="1200" dirty="0">
+                          <a:solidFill>
+                            <a:srgbClr val="1D1D1F"/>
+                          </a:solidFill>
+                          <a:latin typeface="나눔스퀘어 네오 Regular" pitchFamily="34" charset="0"/>
+                          <a:ea typeface="나눔스퀘어 네오 Regular" pitchFamily="34" charset="-122"/>
+                          <a:cs typeface="나눔스퀘어 네오 Regular" pitchFamily="34" charset="-120"/>
+                        </a:rPr>
+                        <a:t>건드려진 행 UZH 52.9%·RobotEvt 55.5%(기준 50% 이하 미달), 칸은 13~17%</a:t>
+                      </a:r>
+                      <a:endParaRPr lang="en-US" sz="1200" dirty="0">
+                        <a:latin typeface="나눔스퀘어 네오 Regular" charset="0"/>
+                        <a:ea typeface="나눔스퀘어 네오 Regular" charset="0"/>
+                        <a:cs typeface="나눔스퀘어 네오 Regular" charset="0"/>
+                      </a:endParaRPr>
+                    </a:p>
+                  </a:txBody>
+                  <a:tcPr marL="73152" marR="73152" marT="36576" marB="36576" anchor="ctr">
+                    <a:lnL w="6350" cap="flat" cmpd="sng" algn="ctr">
+                      <a:solidFill>
+                        <a:srgbClr val="E0E0E0"/>
+                      </a:solidFill>
+                      <a:prstDash val="solid"/>
+                      <a:round/>
+                      <a:headEnd type="none" w="med" len="med"/>
+                      <a:tailEnd type="none" w="med" len="med"/>
+                    </a:lnL>
+                    <a:lnR w="6350" cap="flat" cmpd="sng" algn="ctr">
+                      <a:solidFill>
+                        <a:srgbClr val="E0E0E0"/>
+                      </a:solidFill>
+                      <a:prstDash val="solid"/>
+                      <a:round/>
+                      <a:headEnd type="none" w="med" len="med"/>
+                      <a:tailEnd type="none" w="med" len="med"/>
+                    </a:lnR>
+                    <a:lnT w="6350" cap="flat" cmpd="sng" algn="ctr">
+                      <a:solidFill>
+                        <a:srgbClr val="E0E0E0"/>
+                      </a:solidFill>
+                      <a:prstDash val="solid"/>
+                      <a:round/>
+                      <a:headEnd type="none" w="med" len="med"/>
+                      <a:tailEnd type="none" w="med" len="med"/>
+                    </a:lnT>
+                    <a:lnB w="6350" cap="flat" cmpd="sng" algn="ctr">
+                      <a:solidFill>
+                        <a:srgbClr val="E0E0E0"/>
+                      </a:solidFill>
+                      <a:prstDash val="solid"/>
+                      <a:round/>
+                      <a:headEnd type="none" w="med" len="med"/>
+                      <a:tailEnd type="none" w="med" len="med"/>
+                    </a:lnB>
+                    <a:solidFill>
+                      <a:srgbClr val="FFFFFF"/>
+                    </a:solidFill>
+                  </a:tcPr>
+                </a:tc>
+              </a:tr>
+              <a:tr h="420624">
+                <a:tc>
+                  <a:txBody>
+                    <a:bodyPr/>
+                    <a:lstStyle/>
+                    <a:p>
+                      <a:pPr eaLnBrk="0" indent="0" marL="0">
+                        <a:buNone/>
+                      </a:pPr>
+                      <a:r>
+                        <a:rPr lang="en-US" sz="1200" dirty="0">
+                          <a:solidFill>
+                            <a:srgbClr val="1D1D1F"/>
+                          </a:solidFill>
+                          <a:latin typeface="나눔스퀘어 네오 Regular" pitchFamily="34" charset="0"/>
+                          <a:ea typeface="나눔스퀘어 네오 Regular" pitchFamily="34" charset="-122"/>
+                          <a:cs typeface="나눔스퀘어 네오 Regular" pitchFamily="34" charset="-120"/>
+                        </a:rPr>
+                        <a:t>기억 소멸(forgetting)</a:t>
+                      </a:r>
+                      <a:endParaRPr lang="en-US" sz="1200" dirty="0">
+                        <a:latin typeface="나눔스퀘어 네오 Regular" charset="0"/>
+                        <a:ea typeface="나눔스퀘어 네오 Regular" charset="0"/>
+                        <a:cs typeface="나눔스퀘어 네오 Regular" charset="0"/>
+                      </a:endParaRPr>
+                    </a:p>
+                  </a:txBody>
+                  <a:tcPr marL="73152" marR="73152" marT="36576" marB="36576" anchor="ctr">
+                    <a:lnL w="6350" cap="flat" cmpd="sng" algn="ctr">
+                      <a:solidFill>
+                        <a:srgbClr val="E0E0E0"/>
+                      </a:solidFill>
+                      <a:prstDash val="solid"/>
+                      <a:round/>
+                      <a:headEnd type="none" w="med" len="med"/>
+                      <a:tailEnd type="none" w="med" len="med"/>
+                    </a:lnL>
+                    <a:lnR w="6350" cap="flat" cmpd="sng" algn="ctr">
+                      <a:solidFill>
+                        <a:srgbClr val="E0E0E0"/>
+                      </a:solidFill>
+                      <a:prstDash val="solid"/>
+                      <a:round/>
+                      <a:headEnd type="none" w="med" len="med"/>
+                      <a:tailEnd type="none" w="med" len="med"/>
+                    </a:lnR>
+                    <a:lnT w="6350" cap="flat" cmpd="sng" algn="ctr">
+                      <a:solidFill>
+                        <a:srgbClr val="E0E0E0"/>
+                      </a:solidFill>
+                      <a:prstDash val="solid"/>
+                      <a:round/>
+                      <a:headEnd type="none" w="med" len="med"/>
+                      <a:tailEnd type="none" w="med" len="med"/>
+                    </a:lnT>
+                    <a:lnB w="6350" cap="flat" cmpd="sng" algn="ctr">
+                      <a:solidFill>
+                        <a:srgbClr val="E0E0E0"/>
+                      </a:solidFill>
+                      <a:prstDash val="solid"/>
+                      <a:round/>
+                      <a:headEnd type="none" w="med" len="med"/>
+                      <a:tailEnd type="none" w="med" len="med"/>
+                    </a:lnB>
+                    <a:solidFill>
+                      <a:srgbClr val="FFFFFF"/>
+                    </a:solidFill>
+                  </a:tcPr>
+                </a:tc>
+                <a:tc>
+                  <a:txBody>
+                    <a:bodyPr/>
+                    <a:lstStyle/>
+                    <a:p>
+                      <a:pPr eaLnBrk="0" indent="0" marL="0">
+                        <a:buNone/>
+                      </a:pPr>
+                      <a:r>
+                        <a:rPr lang="en-US" sz="1200" dirty="0">
+                          <a:solidFill>
+                            <a:srgbClr val="1D1D1F"/>
+                          </a:solidFill>
+                          <a:latin typeface="나눔스퀘어 네오 Bold" pitchFamily="34" charset="0"/>
+                          <a:ea typeface="나눔스퀘어 네오 Bold" pitchFamily="34" charset="-122"/>
+                          <a:cs typeface="나눔스퀘어 네오 Bold" pitchFamily="34" charset="-120"/>
+                        </a:rPr>
+                        <a:t>기각</a:t>
+                      </a:r>
+                      <a:endParaRPr lang="en-US" sz="1200" dirty="0">
+                        <a:latin typeface="나눔스퀘어 네오 Regular" charset="0"/>
+                        <a:ea typeface="나눔스퀘어 네오 Regular" charset="0"/>
+                        <a:cs typeface="나눔스퀘어 네오 Regular" charset="0"/>
+                      </a:endParaRPr>
+                    </a:p>
+                  </a:txBody>
+                  <a:tcPr marL="73152" marR="73152" marT="36576" marB="36576" anchor="ctr">
+                    <a:lnL w="6350" cap="flat" cmpd="sng" algn="ctr">
+                      <a:solidFill>
+                        <a:srgbClr val="E0E0E0"/>
+                      </a:solidFill>
+                      <a:prstDash val="solid"/>
+                      <a:round/>
+                      <a:headEnd type="none" w="med" len="med"/>
+                      <a:tailEnd type="none" w="med" len="med"/>
+                    </a:lnL>
+                    <a:lnR w="6350" cap="flat" cmpd="sng" algn="ctr">
+                      <a:solidFill>
+                        <a:srgbClr val="E0E0E0"/>
+                      </a:solidFill>
+                      <a:prstDash val="solid"/>
+                      <a:round/>
+                      <a:headEnd type="none" w="med" len="med"/>
+                      <a:tailEnd type="none" w="med" len="med"/>
+                    </a:lnR>
+                    <a:lnT w="6350" cap="flat" cmpd="sng" algn="ctr">
+                      <a:solidFill>
+                        <a:srgbClr val="E0E0E0"/>
+                      </a:solidFill>
+                      <a:prstDash val="solid"/>
+                      <a:round/>
+                      <a:headEnd type="none" w="med" len="med"/>
+                      <a:tailEnd type="none" w="med" len="med"/>
+                    </a:lnT>
+                    <a:lnB w="6350" cap="flat" cmpd="sng" algn="ctr">
+                      <a:solidFill>
+                        <a:srgbClr val="E0E0E0"/>
+                      </a:solidFill>
+                      <a:prstDash val="solid"/>
+                      <a:round/>
+                      <a:headEnd type="none" w="med" len="med"/>
+                      <a:tailEnd type="none" w="med" len="med"/>
+                    </a:lnB>
+                    <a:solidFill>
+                      <a:srgbClr val="FFFFFF"/>
+                    </a:solidFill>
+                  </a:tcPr>
+                </a:tc>
+                <a:tc>
+                  <a:txBody>
+                    <a:bodyPr/>
+                    <a:lstStyle/>
+                    <a:p>
+                      <a:pPr eaLnBrk="0" indent="0" marL="0">
+                        <a:buNone/>
+                      </a:pPr>
+                      <a:r>
+                        <a:rPr lang="en-US" sz="1200" dirty="0">
+                          <a:solidFill>
+                            <a:srgbClr val="1D1D1F"/>
+                          </a:solidFill>
+                          <a:latin typeface="나눔스퀘어 네오 Regular" pitchFamily="34" charset="0"/>
+                          <a:ea typeface="나눔스퀘어 네오 Regular" pitchFamily="34" charset="-122"/>
+                          <a:cs typeface="나눔스퀘어 네오 Regular" pitchFamily="34" charset="-120"/>
+                        </a:rPr>
+                        <a:t>카운터 감쇠(K=4096): UZH 23.4°→23.8°, RobotEvt 36.1°→36.0°(0.8배 기준 미달)</a:t>
+                      </a:r>
+                      <a:endParaRPr lang="en-US" sz="1200" dirty="0">
+                        <a:latin typeface="나눔스퀘어 네오 Regular" charset="0"/>
+                        <a:ea typeface="나눔스퀘어 네오 Regular" charset="0"/>
+                        <a:cs typeface="나눔스퀘어 네오 Regular" charset="0"/>
+                      </a:endParaRPr>
+                    </a:p>
+                  </a:txBody>
+                  <a:tcPr marL="73152" marR="73152" marT="36576" marB="36576" anchor="ctr">
+                    <a:lnL w="6350" cap="flat" cmpd="sng" algn="ctr">
+                      <a:solidFill>
+                        <a:srgbClr val="E0E0E0"/>
+                      </a:solidFill>
+                      <a:prstDash val="solid"/>
+                      <a:round/>
+                      <a:headEnd type="none" w="med" len="med"/>
+                      <a:tailEnd type="none" w="med" len="med"/>
+                    </a:lnL>
+                    <a:lnR w="6350" cap="flat" cmpd="sng" algn="ctr">
+                      <a:solidFill>
+                        <a:srgbClr val="E0E0E0"/>
+                      </a:solidFill>
+                      <a:prstDash val="solid"/>
+                      <a:round/>
+                      <a:headEnd type="none" w="med" len="med"/>
+                      <a:tailEnd type="none" w="med" len="med"/>
+                    </a:lnR>
+                    <a:lnT w="6350" cap="flat" cmpd="sng" algn="ctr">
+                      <a:solidFill>
+                        <a:srgbClr val="E0E0E0"/>
+                      </a:solidFill>
+                      <a:prstDash val="solid"/>
+                      <a:round/>
+                      <a:headEnd type="none" w="med" len="med"/>
+                      <a:tailEnd type="none" w="med" len="med"/>
+                    </a:lnT>
+                    <a:lnB w="6350" cap="flat" cmpd="sng" algn="ctr">
+                      <a:solidFill>
+                        <a:srgbClr val="E0E0E0"/>
+                      </a:solidFill>
+                      <a:prstDash val="solid"/>
+                      <a:round/>
+                      <a:headEnd type="none" w="med" len="med"/>
+                      <a:tailEnd type="none" w="med" len="med"/>
+                    </a:lnB>
+                    <a:solidFill>
+                      <a:srgbClr val="FFFFFF"/>
+                    </a:solidFill>
+                  </a:tcPr>
+                </a:tc>
+              </a:tr>
+              <a:tr h="420624">
+                <a:tc>
+                  <a:txBody>
+                    <a:bodyPr/>
+                    <a:lstStyle/>
+                    <a:p>
+                      <a:pPr eaLnBrk="0" indent="0" marL="0">
+                        <a:buNone/>
+                      </a:pPr>
+                      <a:r>
+                        <a:rPr lang="en-US" sz="1200" dirty="0">
+                          <a:solidFill>
+                            <a:srgbClr val="1D1D1F"/>
+                          </a:solidFill>
+                          <a:latin typeface="나눔스퀘어 네오 Regular" pitchFamily="34" charset="0"/>
+                          <a:ea typeface="나눔스퀘어 네오 Regular" pitchFamily="34" charset="-122"/>
+                          <a:cs typeface="나눔스퀘어 네오 Regular" pitchFamily="34" charset="-120"/>
+                        </a:rPr>
+                        <a:t>최근 쓰기 캐시 (감각 기억)</a:t>
+                      </a:r>
+                      <a:endParaRPr lang="en-US" sz="1200" dirty="0">
+                        <a:latin typeface="나눔스퀘어 네오 Regular" charset="0"/>
+                        <a:ea typeface="나눔스퀘어 네오 Regular" charset="0"/>
+                        <a:cs typeface="나눔스퀘어 네오 Regular" charset="0"/>
+                      </a:endParaRPr>
+                    </a:p>
+                  </a:txBody>
+                  <a:tcPr marL="73152" marR="73152" marT="36576" marB="36576" anchor="ctr">
+                    <a:lnL w="6350" cap="flat" cmpd="sng" algn="ctr">
+                      <a:solidFill>
+                        <a:srgbClr val="E0E0E0"/>
+                      </a:solidFill>
+                      <a:prstDash val="solid"/>
+                      <a:round/>
+                      <a:headEnd type="none" w="med" len="med"/>
+                      <a:tailEnd type="none" w="med" len="med"/>
+                    </a:lnL>
+                    <a:lnR w="6350" cap="flat" cmpd="sng" algn="ctr">
+                      <a:solidFill>
+                        <a:srgbClr val="E0E0E0"/>
+                      </a:solidFill>
+                      <a:prstDash val="solid"/>
+                      <a:round/>
+                      <a:headEnd type="none" w="med" len="med"/>
+                      <a:tailEnd type="none" w="med" len="med"/>
+                    </a:lnR>
+                    <a:lnT w="6350" cap="flat" cmpd="sng" algn="ctr">
+                      <a:solidFill>
+                        <a:srgbClr val="E0E0E0"/>
+                      </a:solidFill>
+                      <a:prstDash val="solid"/>
+                      <a:round/>
+                      <a:headEnd type="none" w="med" len="med"/>
+                      <a:tailEnd type="none" w="med" len="med"/>
+                    </a:lnT>
+                    <a:lnB w="6350" cap="flat" cmpd="sng" algn="ctr">
+                      <a:solidFill>
+                        <a:srgbClr val="E0E0E0"/>
+                      </a:solidFill>
+                      <a:prstDash val="solid"/>
+                      <a:round/>
+                      <a:headEnd type="none" w="med" len="med"/>
+                      <a:tailEnd type="none" w="med" len="med"/>
+                    </a:lnB>
+                    <a:solidFill>
+                      <a:srgbClr val="FFFFFF"/>
+                    </a:solidFill>
+                  </a:tcPr>
+                </a:tc>
+                <a:tc>
+                  <a:txBody>
+                    <a:bodyPr/>
+                    <a:lstStyle/>
+                    <a:p>
+                      <a:pPr eaLnBrk="0" indent="0" marL="0">
+                        <a:buNone/>
+                      </a:pPr>
+                      <a:r>
+                        <a:rPr lang="en-US" sz="1200" dirty="0">
+                          <a:solidFill>
+                            <a:srgbClr val="7A7A7A"/>
+                          </a:solidFill>
+                          <a:latin typeface="나눔스퀘어 네오 Bold" pitchFamily="34" charset="0"/>
+                          <a:ea typeface="나눔스퀘어 네오 Bold" pitchFamily="34" charset="-122"/>
+                          <a:cs typeface="나눔스퀘어 네오 Bold" pitchFamily="34" charset="-120"/>
+                        </a:rPr>
+                        <a:t>보류</a:t>
+                      </a:r>
+                      <a:endParaRPr lang="en-US" sz="1200" dirty="0">
+                        <a:latin typeface="나눔스퀘어 네오 Regular" charset="0"/>
+                        <a:ea typeface="나눔스퀘어 네오 Regular" charset="0"/>
+                        <a:cs typeface="나눔스퀘어 네오 Regular" charset="0"/>
+                      </a:endParaRPr>
+                    </a:p>
+                  </a:txBody>
+                  <a:tcPr marL="73152" marR="73152" marT="36576" marB="36576" anchor="ctr">
+                    <a:lnL w="6350" cap="flat" cmpd="sng" algn="ctr">
+                      <a:solidFill>
+                        <a:srgbClr val="E0E0E0"/>
+                      </a:solidFill>
+                      <a:prstDash val="solid"/>
+                      <a:round/>
+                      <a:headEnd type="none" w="med" len="med"/>
+                      <a:tailEnd type="none" w="med" len="med"/>
+                    </a:lnL>
+                    <a:lnR w="6350" cap="flat" cmpd="sng" algn="ctr">
+                      <a:solidFill>
+                        <a:srgbClr val="E0E0E0"/>
+                      </a:solidFill>
+                      <a:prstDash val="solid"/>
+                      <a:round/>
+                      <a:headEnd type="none" w="med" len="med"/>
+                      <a:tailEnd type="none" w="med" len="med"/>
+                    </a:lnR>
+                    <a:lnT w="6350" cap="flat" cmpd="sng" algn="ctr">
+                      <a:solidFill>
+                        <a:srgbClr val="E0E0E0"/>
+                      </a:solidFill>
+                      <a:prstDash val="solid"/>
+                      <a:round/>
+                      <a:headEnd type="none" w="med" len="med"/>
+                      <a:tailEnd type="none" w="med" len="med"/>
+                    </a:lnT>
+                    <a:lnB w="6350" cap="flat" cmpd="sng" algn="ctr">
+                      <a:solidFill>
+                        <a:srgbClr val="E0E0E0"/>
+                      </a:solidFill>
+                      <a:prstDash val="solid"/>
+                      <a:round/>
+                      <a:headEnd type="none" w="med" len="med"/>
+                      <a:tailEnd type="none" w="med" len="med"/>
+                    </a:lnB>
+                    <a:solidFill>
+                      <a:srgbClr val="FFFFFF"/>
+                    </a:solidFill>
+                  </a:tcPr>
+                </a:tc>
+                <a:tc>
+                  <a:txBody>
+                    <a:bodyPr/>
+                    <a:lstStyle/>
+                    <a:p>
+                      <a:pPr eaLnBrk="0" indent="0" marL="0">
+                        <a:buNone/>
+                      </a:pPr>
+                      <a:r>
+                        <a:rPr lang="en-US" sz="1200" dirty="0">
                           <a:solidFill>
                             <a:srgbClr val="1D1D1F"/>
                           </a:solidFill>
@@ -12467,7 +12879,7 @@
                         </a:rPr>
                         <a:t>64항목만 전력 −16%/면적 +5.5%, 필수 아님</a:t>
                       </a:r>
-                      <a:endParaRPr lang="en-US" sz="1300" dirty="0">
+                      <a:endParaRPr lang="en-US" sz="1200" dirty="0">
                         <a:latin typeface="나눔스퀘어 네오 Regular" charset="0"/>
                         <a:ea typeface="나눔스퀘어 네오 Regular" charset="0"/>
                         <a:cs typeface="나눔스퀘어 네오 Regular" charset="0"/>

</xml_diff>

<commit_message>
Server batch results: blink P&R, hold-boost variants (rejected), 1024-angle direct multiplier beats RMCM (§224)
Co-Authored-By: Claude Sonnet 5.5 <noreply@anthropic.com>
Claude-Session: https://claude.ai/code/session_017w9Wz8TNpiESdat1g61ZHB
</commit_message>
<xml_diff>
--- a/submission/REDRED_2차_발표자료.pptx
+++ b/submission/REDRED_2차_발표자료.pptx
@@ -3339,7 +3339,7 @@
           <a:p>
             <a:r>
               <a:rPr lang="en-US" dirty="0"/>
-              <a:t>좌표 변환을 세 가지로 구현해 같은 조건에서 합성했습니다. 직접 행렬 곱, CORDIC, 그리고 RMCM입니다. CORDIC은 곱셈기를 없애니 더 작을 것이라 예상했지만 오히려 면적이 네 배 이상 커졌습니다. 우리 문제는 로컬 좌표가 4가지, 각도 후보가 256가지뿐이라 입력 공간 전체가 4096가지입니다. 그래서 전체를 표 하나로 만든 RMCM이 면적 2.5분의 1, 전력 4.8분의 1로 압승했고 근사 오차도 없습니다. 이 결론은 입력 공간이 좁을 때에 한정된다는 점도 함께 말씀드립니다.</a:t>
+              <a:t>좌표 변환을 세 가지로 구현해 같은 조건에서 합성했습니다. 직접 행렬 곱, CORDIC, 그리고 RMCM입니다. CORDIC은 곱셈기를 없애니 더 작을 것이라 예상했지만 오히려 면적이 네 배 이상 커졌습니다. 우리 문제는 로컬 좌표가 4가지, 각도 후보가 256가지뿐이라 입력 공간 전체가 4096가지입니다. 그래서 전체를 표 하나로 만든 RMCM이 면적 2.5분의 1, 전력 4.8분의 1로 압승했고 근사 오차도 없습니다. 이 결론은 입력 공간이 좁을 때에 한정됩니다. 각도를 1024단계로 늘려 다시 합성했더니 표가 19071제곱마이크로미터, 직접 행렬곱이 5209제곱마이크로미터로 결과가 뒤집혔습니다.</a:t>
             </a:r>
             <a:endParaRPr lang="en-US" dirty="0"/>
           </a:p>
@@ -5527,7 +5527,7 @@
                 <a:ea typeface="나눔스퀘어 네오 Regular" pitchFamily="34" charset="-122"/>
                 <a:cs typeface="나눔스퀘어 네오 Regular" pitchFamily="34" charset="-120"/>
               </a:rPr>
-              <a:t>주의: −71%는 유휴가 길도록 만든 시험 입력의 값이다. 실제 부하에서의 절감은 위 가동 비율에 비례하며, vectorless 전력에서는 두 구성이 같게 나온다(활동도를 모르면 코어가 계속 켜져 있다고 가정).</a:t>
+              <a:t>주의: −71%는 유휴가 길도록 만든 시험 입력의 값이다. 실제 부하에서의 절감은 위 가동 비율에 비례하며, vectorless 전력에서는 두 구성이 같게 나온다(활동도를 모르면 코어가 계속 켜져 있다고 가정). blink top P&amp;R(5.2 ns): DRC·antenna 0, setup +0.022 ns, hold −0.010 ns(181경로), 5.94 mW.</a:t>
             </a:r>
             <a:endParaRPr lang="en-US" sz="1300" dirty="0"/>
           </a:p>
@@ -7903,7 +7903,7 @@
                 <a:ea typeface="나눔스퀘어 네오 Regular" pitchFamily="34" charset="-122"/>
                 <a:cs typeface="나눔스퀘어 네오 Regular" pitchFamily="34" charset="-120"/>
               </a:rPr>
-              <a:t>래치+AND → 통합 클록게이트 셀로 hold 해결. signoff ECO는 setup −0.040 ns로 악화되어 미채택</a:t>
+              <a:t>래치+AND → 통합 클록게이트 셀로 hold 해결. ECO·hold 목표 강화는 setup이 깨져(−0.04~−1.17 ns) 미채택</a:t>
             </a:r>
             <a:endParaRPr lang="en-US" sz="1300" dirty="0"/>
           </a:p>
@@ -13492,7 +13492,7 @@
                 <a:ea typeface="나눔스퀘어 네오 Regular" pitchFamily="34" charset="-122"/>
                 <a:cs typeface="나눔스퀘어 네오 Regular" pitchFamily="34" charset="-120"/>
               </a:rPr>
-              <a:t>• 좌표 변환 표(RMCM)는 1024각도로 늘리면 항목이 16배(16,384가지)가 되어 면적이 15.9배(1,199→19,071 µm²). 이 크기에서 직접 행렬곱과의 비교는 아직 안 함</a:t>
+              <a:t>• 1024각도 목표 크기에서는 좌표 변환 표(RMCM) 19,071 µm²가 직접 행렬곱 5,209 µm²보다 3.7배 커서 직접 행렬곱이 맞음(단, 슬랙 0 ps로 여유 없음)</a:t>
             </a:r>
             <a:endParaRPr lang="en-US" sz="1400" dirty="0"/>
           </a:p>
@@ -13724,7 +13724,7 @@
                 <a:ea typeface="나눔스퀘어 네오 Regular" pitchFamily="34" charset="-122"/>
                 <a:cs typeface="나눔스퀘어 네오 Regular" pitchFamily="34" charset="-120"/>
               </a:rPr>
-              <a:t>표 기반 좌표 변환 (면적 2.5배↓, 전력 4.8배↓)</a:t>
+              <a:t>표 기반 좌표 변환 (256각도에서 면적 2.5배↓, 전력 4.8배↓)</a:t>
             </a:r>
             <a:endParaRPr lang="en-US" sz="1700" dirty="0"/>
           </a:p>
@@ -17519,7 +17519,7 @@
                 <a:ea typeface="나눔스퀘어 네오 Bold" pitchFamily="34" charset="-122"/>
                 <a:cs typeface="나눔스퀘어 네오 Bold" pitchFamily="34" charset="-120"/>
               </a:rPr>
-              <a:t>좌표 변환은 계산을 줄이지 않고 아예 표로 바꿨다</a:t>
+              <a:t>좌표 변환: 256각도에서는 계산 대신 표가 이겼다</a:t>
             </a:r>
             <a:endParaRPr lang="en-US" sz="2600" dirty="0"/>
           </a:p>
@@ -18172,7 +18172,7 @@
                 <a:ea typeface="나눔스퀘어 네오 Regular" pitchFamily="34" charset="-122"/>
                 <a:cs typeface="나눔스퀘어 네오 Regular" pitchFamily="34" charset="-120"/>
               </a:rPr>
-              <a:t>Genus 합성, 5 ns, GPDK045. 입력 4096가지(256각도) 기준, RMCM은 직접 행렬곱과 bit-exact. 1024각도 RMCM(16,384가지)은 면적 19,071 µm², 0.297 mW, 슬랙 +1,178 ps(256각도의 15.9배 면적).</a:t>
+              <a:t>Genus 합성, 5 ns, GPDK045. 입력 4096가지(256각도) 기준, RMCM은 직접 행렬곱과 bit-exact. 1024각도에서는 RMCM 19,071 µm²·0.297 mW·+1,178 ps, 직접 행렬곱 5,209 µm²·0.279 mW·0 ps.</a:t>
             </a:r>
             <a:endParaRPr lang="en-US" sz="1300" dirty="0"/>
           </a:p>
@@ -18238,7 +18238,7 @@
                 <a:ea typeface="나눔스퀘어 네오 Bold" pitchFamily="34" charset="-122"/>
                 <a:cs typeface="나눔스퀘어 네오 Bold" pitchFamily="34" charset="-120"/>
               </a:rPr>
-              <a:t>곱셈기를 없애는 것이 항상 이득은 아니다. 입력 후보가 몇 가지로 좁을 때는 계산을 없애고 표로 대체하는 쪽이 이겼다. (이 결론은 입력 공간이 큰 경우엔 달라질 수 있다.)</a:t>
+              <a:t>곱셈기를 없애는 것이 항상 이득은 아니다. 256각도(입력 4,096가지)에서는 표가 이겼지만, 1024각도(16,384가지)에서는 표가 직접 행렬곱보다 3.7배 커서 결과가 뒤집혔다.</a:t>
             </a:r>
             <a:endParaRPr lang="en-US" sz="1600" dirty="0"/>
           </a:p>

</xml_diff>

<commit_message>
Deck: reflect hold fix (slide 12 table/text, slide 19 summary), regenerate pptx/pdf (§229)
Co-Authored-By: Claude Sonnet 5.5 <noreply@anthropic.com>
Claude-Session: https://claude.ai/code/session_017w9Wz8TNpiESdat1g61ZHB
</commit_message>
<xml_diff>
--- a/submission/REDRED_2차_발표자료.pptx
+++ b/submission/REDRED_2차_발표자료.pptx
@@ -2371,7 +2371,7 @@
           <a:p>
             <a:r>
               <a:rPr lang="en-US" dirty="0"/>
-              <a:t>배치배선까지 완주해 Quantus 추출 기반 signoff 수준으로 재타이밍했습니다. 래치와 AND 게이트를 따로 둔 행 게이팅 설계는 DRC와 antenna는 0건이었지만 클록 게이팅 hold가 최악 마이너스 30피코초였습니다. 원인은 클록 트리 합성이 래치를 말단 싱크로 보고 균형을 맞추면서 래치가 AND 게이트보다 0.2나노초 일찍 열린 것이었습니다. 라이브러리의 통합 클록 게이트 셀로 바꾸자 클록 게이팅 hold 위반은 0건이 됐습니다. 다만 5나노초에서 일반 레지스터 경로에 hold 마이너스 7피코초, setup 마이너스 19피코초 위반이 남았고, signoff 단계 ECO로는 setup이 오히려 나빠져 채택하지 않았습니다. 클록을 5.2나노초로 늦춘 결과는 오른쪽 열에 적었습니다.</a:t>
+              <a:t>배치배선까지 완주해 Quantus 추출 기반 signoff 수준으로 재타이밍했습니다. 래치와 AND 게이트를 따로 둔 행 게이팅 설계는 DRC와 antenna는 0건이었지만 클록 게이팅 hold가 최악 마이너스 30피코초였습니다. 원인은 클록 트리 합성이 래치를 말단 싱크로 보고 균형을 맞추면서 래치가 AND 게이트보다 0.2나노초 일찍 열린 것이었습니다. 라이브러리의 통합 클록 게이트 셀로 바꾸자 클록 게이팅 hold 위반은 0건이 됐습니다. 다만 일반 레지스터 경로에는 hold 마이너스 7피코초가 남았습니다. 이 경로는 월드 메모리 플립플롭이 자기 자신으로 돌아오는 짧은 경로입니다. 지연 버퍼를 새로 넣는 방법은 메모리 배열에 빈자리가 없어 버퍼가 멀리 밀려나면서 setup이 깨졌습니다. 그래서 해당 경로의 선택 회로 292개를 한 단계 느린 셀로 교체하고 남은 setup 위반 한 경로를 후처리로 고쳤습니다. 5.2나노초에서 hold와 setup 위반이 모두 0건이 됐고, RTL과 배치배선 넷리스트의 게이트 시뮬레이션도 일치합니다. 오른쪽 열이 그 결과입니다. hold 여유는 3피코초로 얇습니다.</a:t>
             </a:r>
             <a:endParaRPr lang="en-US" dirty="0"/>
           </a:p>
@@ -5641,7 +5641,7 @@
                 <a:ea typeface="나눔스퀘어 네오 Bold" pitchFamily="34" charset="-122"/>
                 <a:cs typeface="나눔스퀘어 네오 Bold" pitchFamily="34" charset="-120"/>
               </a:rPr>
-              <a:t>물리 검증: 클록 게이팅 hold는 구조로 해결, 일반 경로에 ps 단위 잔여</a:t>
+              <a:t>물리 검증: hold는 구조 수정과 ECO로 해결, 5.2 ns에서 위반 0건</a:t>
             </a:r>
             <a:endParaRPr lang="en-US" sz="2600" dirty="0"/>
           </a:p>
@@ -5897,7 +5897,7 @@
                           <a:ea typeface="나눔스퀘어 네오 Bold" pitchFamily="34" charset="-122"/>
                           <a:cs typeface="나눔스퀘어 네오 Bold" pitchFamily="34" charset="-120"/>
                         </a:rPr>
-                        <a:t>통합 ICG @5.2 ns</a:t>
+                        <a:t>통합 ICG @5.2 ns + hold ECO</a:t>
                       </a:r>
                       <a:endParaRPr lang="en-US" sz="1200" dirty="0">
                         <a:latin typeface="나눔스퀘어 네오 Regular" charset="0"/>
@@ -6719,7 +6719,7 @@
                           <a:ea typeface="나눔스퀘어 네오 Regular" pitchFamily="34" charset="-122"/>
                           <a:cs typeface="나눔스퀘어 네오 Regular" pitchFamily="34" charset="-120"/>
                         </a:rPr>
-                        <a:t>-0.007 ns (61)</a:t>
+                        <a:t>+0.003 ns (0)</a:t>
                       </a:r>
                       <a:endParaRPr lang="en-US" sz="1200" dirty="0">
                         <a:latin typeface="나눔스퀘어 네오 Regular" charset="0"/>
@@ -6993,7 +6993,7 @@
                           <a:ea typeface="나눔스퀘어 네오 Regular" pitchFamily="34" charset="-122"/>
                           <a:cs typeface="나눔스퀘어 네오 Regular" pitchFamily="34" charset="-120"/>
                         </a:rPr>
-                        <a:t>+0.077 ns (0)</a:t>
+                        <a:t>+0.028 ns (0)</a:t>
                       </a:r>
                       <a:endParaRPr lang="en-US" sz="1200" dirty="0">
                         <a:latin typeface="나눔스퀘어 네오 Regular" charset="0"/>
@@ -7267,7 +7267,7 @@
                           <a:ea typeface="나눔스퀘어 네오 Regular" pitchFamily="34" charset="-122"/>
                           <a:cs typeface="나눔스퀘어 네오 Regular" pitchFamily="34" charset="-120"/>
                         </a:rPr>
-                        <a:t>5.72 mW</a:t>
+                        <a:t>5.75 mW</a:t>
                       </a:r>
                       <a:endParaRPr lang="en-US" sz="1200" dirty="0">
                         <a:latin typeface="나눔스퀘어 네오 Regular" charset="0"/>
@@ -7541,7 +7541,7 @@
                           <a:ea typeface="나눔스퀘어 네오 Regular" pitchFamily="34" charset="-122"/>
                           <a:cs typeface="나눔스퀘어 네오 Regular" pitchFamily="34" charset="-120"/>
                         </a:rPr>
-                        <a:t>160,213 µm²</a:t>
+                        <a:t>160,682 µm²</a:t>
                       </a:r>
                       <a:endParaRPr lang="en-US" sz="1200" dirty="0">
                         <a:latin typeface="나눔스퀘어 네오 Regular" charset="0"/>
@@ -7630,7 +7630,7 @@
                 <a:ea typeface="나눔스퀘어 네오 Regular" pitchFamily="34" charset="-122"/>
                 <a:cs typeface="나눔스퀘어 네오 Regular" pitchFamily="34" charset="-120"/>
               </a:rPr>
-              <a:t>괄호 안은 위반 경로 수. 5 ns, util 0.6, GPDK045, Quantus 추출.</a:t>
+              <a:t>괄호 안은 위반 경로 수. 앞 두 열 5.0 ns, 오른쪽 열 5.2 ns, util 0.6, GPDK045, Quantus 추출.</a:t>
             </a:r>
             <a:endParaRPr lang="en-US" sz="1100" dirty="0"/>
           </a:p>
@@ -7903,7 +7903,7 @@
                 <a:ea typeface="나눔스퀘어 네오 Regular" pitchFamily="34" charset="-122"/>
                 <a:cs typeface="나눔스퀘어 네오 Regular" pitchFamily="34" charset="-120"/>
               </a:rPr>
-              <a:t>래치+AND → 통합 클록게이트 셀로 hold 해결. ECO·hold 목표 강화는 setup이 깨져(−0.04~−1.17 ns) 미채택</a:t>
+              <a:t>래치+AND → 통합 클록게이트 셀. reg2reg hold는 hold mux 292개를 느린 셀로 교체하는 ECO로 해결(5.2 ns)</a:t>
             </a:r>
             <a:endParaRPr lang="en-US" sz="1300" dirty="0"/>
           </a:p>
@@ -8008,7 +8008,7 @@
                 <a:ea typeface="나눔스퀘어 네오 Regular" pitchFamily="34" charset="-122"/>
                 <a:cs typeface="나눔스퀘어 네오 Regular" pitchFamily="34" charset="-120"/>
               </a:rPr>
-              <a:t>일반 경로 ps 단위 잔여 위반. 클록 여유로 흡수하는 것이 현재 해법</a:t>
+              <a:t>hold 여유 +3 ps로 얇음(팀 공통 uncertainty 0.1 ns 기준). 5.0 ns 설계와 blink top에는 미적용</a:t>
             </a:r>
             <a:endParaRPr lang="en-US" sz="1300" dirty="0"/>
           </a:p>
@@ -13869,7 +13869,7 @@
                 <a:ea typeface="나눔스퀘어 네오 Regular" pitchFamily="34" charset="-122"/>
                 <a:cs typeface="나눔스퀘어 네오 Regular" pitchFamily="34" charset="-120"/>
               </a:rPr>
-              <a:t>P&amp;R: DRC·antenna 0건, 클록 게이팅 hold는 ICG로 해결</a:t>
+              <a:t>P&amp;R(5.2 ns, 행 게이팅 통합 설계): DRC·antenna·hold·setup 위반 0건 (blink 포함 top은 hold −10 ps 잔여)</a:t>
             </a:r>
             <a:endParaRPr lang="en-US" sz="1700" dirty="0"/>
           </a:p>

</xml_diff>

<commit_message>
Deck: keyframe SLAM rejection row, estimator synthesis+P&R caveat, blink top hold fixed (11/12/13/17/19)
Co-Authored-By: Claude Sonnet 5.5 <noreply@anthropic.com>
Claude-Session: https://claude.ai/code/session_017w9Wz8TNpiESdat1g61ZHB
</commit_message>
<xml_diff>
--- a/submission/REDRED_2차_발표자료.pptx
+++ b/submission/REDRED_2차_발표자료.pptx
@@ -2811,7 +2811,7 @@
           <a:p>
             <a:r>
               <a:rPr lang="en-US" dirty="0"/>
-              <a:t>생체 모방 아이디어를 여러 개 시도했지만, 합성 장면에서만 이득이 나온 것은 실제 프레임으로 확인해 기각했습니다. 눈 깜빡임을 본뜬 유휴 클록 차단과, 메모리 행 단위 클록 게이팅은 실제 데이터로 이득이 확인되어 채택했습니다. 반대로 이득 조절은 합성 장면에서는 좋아 보였지만 실제 DELTA 프레임에서는 이득이 없어서 정정했습니다. 습관화, 도약성 억제, 미세 안구운동, 추정기 입력 줄이기도 사전에 정한 기준을 넘지 못해 기각했습니다. 무엇을 안 했는지도 설계의 일부라고 생각합니다.</a:t>
+              <a:t>생체 모방 아이디어를 여러 개 시도했지만, 합성 장면에서만 이득이 나온 것은 실제 프레임으로 확인해 기각했습니다. 눈 깜빡임을 본뜬 유휴 클록 차단과, 메모리 행 단위 클록 게이팅은 실제 데이터로 이득이 확인되어 채택했습니다. 반대로 이득 조절은 합성 장면에서는 좋아 보였지만 실제 DELTA 프레임에서는 이득이 없어서 정정했습니다. 습관화, 도약성 억제, 미세 안구운동, 추정기 입력 줄이기도 사전에 정한 기준을 넘지 못해 기각했습니다. 지도 제작 방식으로는 키프레임과 루프 클로저를 쓰는 SLAM식 구조도 시험했는데, 합성 데이터와 실제 DELTA 영상 모두에서 현재 구조보다 나아지지 않고 메모리만 커져서 채택하지 않았습니다. 무엇을 안 했는지도 설계의 일부라고 생각합니다.</a:t>
             </a:r>
             <a:endParaRPr lang="en-US" dirty="0"/>
           </a:p>
@@ -5527,7 +5527,7 @@
                 <a:ea typeface="나눔스퀘어 네오 Regular" pitchFamily="34" charset="-122"/>
                 <a:cs typeface="나눔스퀘어 네오 Regular" pitchFamily="34" charset="-120"/>
               </a:rPr>
-              <a:t>주의: −71%는 유휴가 길도록 만든 시험 입력의 값이다. 실제 부하에서의 절감은 위 가동 비율에 비례하며, vectorless 전력에서는 두 구성이 같게 나온다(활동도를 모르면 코어가 계속 켜져 있다고 가정). blink top P&amp;R(5.2 ns): DRC·antenna 0, setup +0.022 ns, hold −0.010 ns(181경로), 5.94 mW.</a:t>
+              <a:t>주의: −71%는 유휴가 길도록 만든 시험 입력의 값이다. 실제 부하에서의 절감은 위 가동 비율에 비례하며, vectorless 전력에서는 두 구성이 같게 나온다(활동도를 모르면 코어가 계속 켜져 있다고 가정). blink top P&amp;R(5.2 ns, hold ECO 후): DRC·antenna 0, setup +0.069 ns, hold 위반 0(여유 0 ps), 5.97 mW. ECO 전에는 hold −0.010 ns(181경로).</a:t>
             </a:r>
             <a:endParaRPr lang="en-US" sz="1300" dirty="0"/>
           </a:p>
@@ -8008,7 +8008,7 @@
                 <a:ea typeface="나눔스퀘어 네오 Regular" pitchFamily="34" charset="-122"/>
                 <a:cs typeface="나눔스퀘어 네오 Regular" pitchFamily="34" charset="-120"/>
               </a:rPr>
-              <a:t>hold 여유 +3 ps로 얇음(팀 공통 uncertainty 0.1 ns 기준). 5.0 ns 설계와 blink top에는 미적용</a:t>
+              <a:t>hold 여유 +3 ps로 얇음(팀 공통 uncertainty 0.1 ns 기준). 5.0 ns는 setup이 안 닫힘(원본도 −19 ps). blink top 5.2 ns도 같은 ECO로 위반 0</a:t>
             </a:r>
             <a:endParaRPr lang="en-US" sz="1300" dirty="0"/>
           </a:p>
@@ -9343,7 +9343,7 @@
               <a:buNone/>
             </a:pPr>
             <a:r>
-              <a:rPr lang="en-US" sz="1300" dirty="0">
+              <a:rPr lang="en-US" sz="1200" dirty="0">
                 <a:solidFill>
                   <a:srgbClr val="1D1D1F"/>
                 </a:solidFill>
@@ -9351,9 +9351,9 @@
                 <a:ea typeface="나눔스퀘어 네오 Regular" pitchFamily="34" charset="-122"/>
                 <a:cs typeface="나눔스퀘어 네오 Regular" pitchFamily="34" charset="-120"/>
               </a:rPr>
-              <a:t>이산 베이즈 필터를 고정소수점으로 구현. UZH 이벤트 300개 재생에서 오라클과 비트 단위로 일치(1024각도 버전).</a:t>
+              <a:t>고정소수점 이산 베이즈 필터, UZH 300개 재생에서 오라클과 비트 단위 일치. 합성 584,631 µm²·14.5 mW(60%가 belief 메모리 FF), 단독 P&amp;R은 타이밍 미달(−17.7 ns) → SRAM 필요.</a:t>
             </a:r>
-            <a:endParaRPr lang="en-US" sz="1300" dirty="0"/>
+            <a:endParaRPr lang="en-US" sz="1200" dirty="0"/>
           </a:p>
         </p:txBody>
       </p:sp>
@@ -10663,7 +10663,7 @@
                 <a:gridCol w="1188720"/>
                 <a:gridCol w="5852160"/>
               </a:tblGrid>
-              <a:tr h="420624">
+              <a:tr h="384048">
                 <a:tc>
                   <a:txBody>
                     <a:bodyPr/>
@@ -10869,7 +10869,7 @@
                   </a:tcPr>
                 </a:tc>
               </a:tr>
-              <a:tr h="420624">
+              <a:tr h="384048">
                 <a:tc>
                   <a:txBody>
                     <a:bodyPr/>
@@ -11075,7 +11075,7 @@
                   </a:tcPr>
                 </a:tc>
               </a:tr>
-              <a:tr h="420624">
+              <a:tr h="384048">
                 <a:tc>
                   <a:txBody>
                     <a:bodyPr/>
@@ -11281,7 +11281,7 @@
                   </a:tcPr>
                 </a:tc>
               </a:tr>
-              <a:tr h="420624">
+              <a:tr h="384048">
                 <a:tc>
                   <a:txBody>
                     <a:bodyPr/>
@@ -11487,7 +11487,7 @@
                   </a:tcPr>
                 </a:tc>
               </a:tr>
-              <a:tr h="420624">
+              <a:tr h="384048">
                 <a:tc>
                   <a:txBody>
                     <a:bodyPr/>
@@ -11693,7 +11693,7 @@
                   </a:tcPr>
                 </a:tc>
               </a:tr>
-              <a:tr h="420624">
+              <a:tr h="384048">
                 <a:tc>
                   <a:txBody>
                     <a:bodyPr/>
@@ -11899,7 +11899,7 @@
                   </a:tcPr>
                 </a:tc>
               </a:tr>
-              <a:tr h="420624">
+              <a:tr h="384048">
                 <a:tc>
                   <a:txBody>
                     <a:bodyPr/>
@@ -12105,7 +12105,7 @@
                   </a:tcPr>
                 </a:tc>
               </a:tr>
-              <a:tr h="420624">
+              <a:tr h="384048">
                 <a:tc>
                   <a:txBody>
                     <a:bodyPr/>
@@ -12311,7 +12311,7 @@
                   </a:tcPr>
                 </a:tc>
               </a:tr>
-              <a:tr h="420624">
+              <a:tr h="384048">
                 <a:tc>
                   <a:txBody>
                     <a:bodyPr/>
@@ -12517,7 +12517,7 @@
                   </a:tcPr>
                 </a:tc>
               </a:tr>
-              <a:tr h="420624">
+              <a:tr h="384048">
                 <a:tc>
                   <a:txBody>
                     <a:bodyPr/>
@@ -12723,7 +12723,213 @@
                   </a:tcPr>
                 </a:tc>
               </a:tr>
-              <a:tr h="420624">
+              <a:tr h="384048">
+                <a:tc>
+                  <a:txBody>
+                    <a:bodyPr/>
+                    <a:lstStyle/>
+                    <a:p>
+                      <a:pPr eaLnBrk="0" indent="0" marL="0">
+                        <a:buNone/>
+                      </a:pPr>
+                      <a:r>
+                        <a:rPr lang="en-US" sz="1200" dirty="0">
+                          <a:solidFill>
+                            <a:srgbClr val="1D1D1F"/>
+                          </a:solidFill>
+                          <a:latin typeface="나눔스퀘어 네오 Regular" pitchFamily="34" charset="0"/>
+                          <a:ea typeface="나눔스퀘어 네오 Regular" pitchFamily="34" charset="-122"/>
+                          <a:cs typeface="나눔스퀘어 네오 Regular" pitchFamily="34" charset="-120"/>
+                        </a:rPr>
+                        <a:t>키프레임(SLAM): 키프레임 + 자세 그래프 + 루프 클로저</a:t>
+                      </a:r>
+                      <a:endParaRPr lang="en-US" sz="1200" dirty="0">
+                        <a:latin typeface="나눔스퀘어 네오 Regular" charset="0"/>
+                        <a:ea typeface="나눔스퀘어 네오 Regular" charset="0"/>
+                        <a:cs typeface="나눔스퀘어 네오 Regular" charset="0"/>
+                      </a:endParaRPr>
+                    </a:p>
+                  </a:txBody>
+                  <a:tcPr marL="73152" marR="73152" marT="36576" marB="36576" anchor="ctr">
+                    <a:lnL w="6350" cap="flat" cmpd="sng" algn="ctr">
+                      <a:solidFill>
+                        <a:srgbClr val="E0E0E0"/>
+                      </a:solidFill>
+                      <a:prstDash val="solid"/>
+                      <a:round/>
+                      <a:headEnd type="none" w="med" len="med"/>
+                      <a:tailEnd type="none" w="med" len="med"/>
+                    </a:lnL>
+                    <a:lnR w="6350" cap="flat" cmpd="sng" algn="ctr">
+                      <a:solidFill>
+                        <a:srgbClr val="E0E0E0"/>
+                      </a:solidFill>
+                      <a:prstDash val="solid"/>
+                      <a:round/>
+                      <a:headEnd type="none" w="med" len="med"/>
+                      <a:tailEnd type="none" w="med" len="med"/>
+                    </a:lnR>
+                    <a:lnT w="6350" cap="flat" cmpd="sng" algn="ctr">
+                      <a:solidFill>
+                        <a:srgbClr val="E0E0E0"/>
+                      </a:solidFill>
+                      <a:prstDash val="solid"/>
+                      <a:round/>
+                      <a:headEnd type="none" w="med" len="med"/>
+                      <a:tailEnd type="none" w="med" len="med"/>
+                    </a:lnT>
+                    <a:lnB w="6350" cap="flat" cmpd="sng" algn="ctr">
+                      <a:solidFill>
+                        <a:srgbClr val="E0E0E0"/>
+                      </a:solidFill>
+                      <a:prstDash val="solid"/>
+                      <a:round/>
+                      <a:headEnd type="none" w="med" len="med"/>
+                      <a:tailEnd type="none" w="med" len="med"/>
+                    </a:lnB>
+                    <a:solidFill>
+                      <a:srgbClr val="FFFFFF"/>
+                    </a:solidFill>
+                  </a:tcPr>
+                </a:tc>
+                <a:tc>
+                  <a:txBody>
+                    <a:bodyPr/>
+                    <a:lstStyle/>
+                    <a:p>
+                      <a:pPr eaLnBrk="0" indent="0" marL="0">
+                        <a:buNone/>
+                      </a:pPr>
+                      <a:r>
+                        <a:rPr lang="en-US" sz="1200" dirty="0">
+                          <a:solidFill>
+                            <a:srgbClr val="1D1D1F"/>
+                          </a:solidFill>
+                          <a:latin typeface="나눔스퀘어 네오 Bold" pitchFamily="34" charset="0"/>
+                          <a:ea typeface="나눔스퀘어 네오 Bold" pitchFamily="34" charset="-122"/>
+                          <a:cs typeface="나눔스퀘어 네오 Bold" pitchFamily="34" charset="-120"/>
+                        </a:rPr>
+                        <a:t>기각</a:t>
+                      </a:r>
+                      <a:endParaRPr lang="en-US" sz="1200" dirty="0">
+                        <a:latin typeface="나눔스퀘어 네오 Regular" charset="0"/>
+                        <a:ea typeface="나눔스퀘어 네오 Regular" charset="0"/>
+                        <a:cs typeface="나눔스퀘어 네오 Regular" charset="0"/>
+                      </a:endParaRPr>
+                    </a:p>
+                  </a:txBody>
+                  <a:tcPr marL="73152" marR="73152" marT="36576" marB="36576" anchor="ctr">
+                    <a:lnL w="6350" cap="flat" cmpd="sng" algn="ctr">
+                      <a:solidFill>
+                        <a:srgbClr val="E0E0E0"/>
+                      </a:solidFill>
+                      <a:prstDash val="solid"/>
+                      <a:round/>
+                      <a:headEnd type="none" w="med" len="med"/>
+                      <a:tailEnd type="none" w="med" len="med"/>
+                    </a:lnL>
+                    <a:lnR w="6350" cap="flat" cmpd="sng" algn="ctr">
+                      <a:solidFill>
+                        <a:srgbClr val="E0E0E0"/>
+                      </a:solidFill>
+                      <a:prstDash val="solid"/>
+                      <a:round/>
+                      <a:headEnd type="none" w="med" len="med"/>
+                      <a:tailEnd type="none" w="med" len="med"/>
+                    </a:lnR>
+                    <a:lnT w="6350" cap="flat" cmpd="sng" algn="ctr">
+                      <a:solidFill>
+                        <a:srgbClr val="E0E0E0"/>
+                      </a:solidFill>
+                      <a:prstDash val="solid"/>
+                      <a:round/>
+                      <a:headEnd type="none" w="med" len="med"/>
+                      <a:tailEnd type="none" w="med" len="med"/>
+                    </a:lnT>
+                    <a:lnB w="6350" cap="flat" cmpd="sng" algn="ctr">
+                      <a:solidFill>
+                        <a:srgbClr val="E0E0E0"/>
+                      </a:solidFill>
+                      <a:prstDash val="solid"/>
+                      <a:round/>
+                      <a:headEnd type="none" w="med" len="med"/>
+                      <a:tailEnd type="none" w="med" len="med"/>
+                    </a:lnB>
+                    <a:solidFill>
+                      <a:srgbClr val="FFFFFF"/>
+                    </a:solidFill>
+                  </a:tcPr>
+                </a:tc>
+                <a:tc>
+                  <a:txBody>
+                    <a:bodyPr/>
+                    <a:lstStyle/>
+                    <a:p>
+                      <a:pPr eaLnBrk="0" indent="0" marL="0">
+                        <a:buNone/>
+                      </a:pPr>
+                      <a:r>
+                        <a:rPr lang="en-US" sz="1200" dirty="0">
+                          <a:solidFill>
+                            <a:srgbClr val="1D1D1F"/>
+                          </a:solidFill>
+                          <a:latin typeface="나눔스퀘어 네오 Regular" pitchFamily="34" charset="0"/>
+                          <a:ea typeface="나눔스퀘어 네오 Regular" pitchFamily="34" charset="-122"/>
+                          <a:cs typeface="나눔스퀘어 네오 Regular" pitchFamily="34" charset="-120"/>
+                        </a:rPr>
+                        <a:t>합성 오차 0.35~0.40°(현재) 대 0.43~1.0°, 실제 DELTA 지도 정합 0.241 → 0.18~0.20, 메모리 3.7배(7.86 Mbit)</a:t>
+                      </a:r>
+                      <a:endParaRPr lang="en-US" sz="1200" dirty="0">
+                        <a:latin typeface="나눔스퀘어 네오 Regular" charset="0"/>
+                        <a:ea typeface="나눔스퀘어 네오 Regular" charset="0"/>
+                        <a:cs typeface="나눔스퀘어 네오 Regular" charset="0"/>
+                      </a:endParaRPr>
+                    </a:p>
+                  </a:txBody>
+                  <a:tcPr marL="73152" marR="73152" marT="36576" marB="36576" anchor="ctr">
+                    <a:lnL w="6350" cap="flat" cmpd="sng" algn="ctr">
+                      <a:solidFill>
+                        <a:srgbClr val="E0E0E0"/>
+                      </a:solidFill>
+                      <a:prstDash val="solid"/>
+                      <a:round/>
+                      <a:headEnd type="none" w="med" len="med"/>
+                      <a:tailEnd type="none" w="med" len="med"/>
+                    </a:lnL>
+                    <a:lnR w="6350" cap="flat" cmpd="sng" algn="ctr">
+                      <a:solidFill>
+                        <a:srgbClr val="E0E0E0"/>
+                      </a:solidFill>
+                      <a:prstDash val="solid"/>
+                      <a:round/>
+                      <a:headEnd type="none" w="med" len="med"/>
+                      <a:tailEnd type="none" w="med" len="med"/>
+                    </a:lnR>
+                    <a:lnT w="6350" cap="flat" cmpd="sng" algn="ctr">
+                      <a:solidFill>
+                        <a:srgbClr val="E0E0E0"/>
+                      </a:solidFill>
+                      <a:prstDash val="solid"/>
+                      <a:round/>
+                      <a:headEnd type="none" w="med" len="med"/>
+                      <a:tailEnd type="none" w="med" len="med"/>
+                    </a:lnT>
+                    <a:lnB w="6350" cap="flat" cmpd="sng" algn="ctr">
+                      <a:solidFill>
+                        <a:srgbClr val="E0E0E0"/>
+                      </a:solidFill>
+                      <a:prstDash val="solid"/>
+                      <a:round/>
+                      <a:headEnd type="none" w="med" len="med"/>
+                      <a:tailEnd type="none" w="med" len="med"/>
+                    </a:lnB>
+                    <a:solidFill>
+                      <a:srgbClr val="FFFFFF"/>
+                    </a:solidFill>
+                  </a:tcPr>
+                </a:tc>
+              </a:tr>
+              <a:tr h="384048">
                 <a:tc>
                   <a:txBody>
                     <a:bodyPr/>
@@ -13869,7 +14075,7 @@
                 <a:ea typeface="나눔스퀘어 네오 Regular" pitchFamily="34" charset="-122"/>
                 <a:cs typeface="나눔스퀘어 네오 Regular" pitchFamily="34" charset="-120"/>
               </a:rPr>
-              <a:t>P&amp;R(5.2 ns, 행 게이팅 통합 설계): DRC·antenna·hold·setup 위반 0건 (blink 포함 top은 hold −10 ps 잔여)</a:t>
+              <a:t>P&amp;R(5.2 ns, 행 게이팅 통합 설계와 blink top): DRC·antenna·hold·setup 위반 0건</a:t>
             </a:r>
             <a:endParaRPr lang="en-US" sz="1700" dirty="0"/>
           </a:p>

</xml_diff>

<commit_message>
1024-angle RMCM P&R: DRC 10000+, setup -20.9ns vs direct multiplier DRC 0, -0.099ns; deck slide 5 updated (§231)
Co-Authored-By: Claude Sonnet 5.5 <noreply@anthropic.com>
Claude-Session: https://claude.ai/code/session_017w9Wz8TNpiESdat1g61ZHB
</commit_message>
<xml_diff>
--- a/submission/REDRED_2차_발표자료.pptx
+++ b/submission/REDRED_2차_발표자료.pptx
@@ -3339,7 +3339,7 @@
           <a:p>
             <a:r>
               <a:rPr lang="en-US" dirty="0"/>
-              <a:t>좌표 변환을 세 가지로 구현해 같은 조건에서 합성했습니다. 직접 행렬 곱, CORDIC, 그리고 RMCM입니다. CORDIC은 곱셈기를 없애니 더 작을 것이라 예상했지만 오히려 면적이 네 배 이상 커졌습니다. 우리 문제는 로컬 좌표가 4가지, 각도 후보가 256가지뿐이라 입력 공간 전체가 4096가지입니다. 그래서 전체를 표 하나로 만든 RMCM이 면적 2.5분의 1, 전력 4.8분의 1로 압승했고 근사 오차도 없습니다. 이 결론은 입력 공간이 좁을 때에 한정됩니다. 각도를 1024단계로 늘려 다시 합성했더니 표가 19071제곱마이크로미터, 직접 행렬곱이 5209제곱마이크로미터로 결과가 뒤집혔습니다.</a:t>
+              <a:t>좌표 변환을 세 가지로 구현해 같은 조건에서 합성했습니다. 직접 행렬 곱, CORDIC, 그리고 RMCM입니다. CORDIC은 곱셈기를 없애니 더 작을 것이라 예상했지만 오히려 면적이 네 배 이상 커졌습니다. 우리 문제는 로컬 좌표가 4가지, 각도 후보가 256가지뿐이라 입력 공간 전체가 4096가지입니다. 그래서 전체를 표 하나로 만든 RMCM이 면적 2.5분의 1, 전력 4.8분의 1로 압승했고 근사 오차도 없습니다. 이 결론은 입력 공간이 좁을 때에 한정됩니다. 각도를 1024단계로 늘려 다시 합성했더니 표가 19071제곱마이크로미터, 직접 행렬곱이 5209제곱마이크로미터로 결과가 뒤집혔습니다. 배치배선까지 해 보니 차이가 더 커졌습니다. 직접 행렬곱은 면적 7354제곱마이크로미터에 DRC 위반이 없고 setup이 0.1나노초 모자란 수준이지만, 표는 면적 33935제곱마이크로미터에 배선이 풀리지 않아 DRC 위반이 1만 건 이상이고 타이밍도 크게 어긋났습니다. 그래서 목표 크기인 1024각도에서는 직접 행렬곱이 맞다고 판단합니다.</a:t>
             </a:r>
             <a:endParaRPr lang="en-US" dirty="0"/>
           </a:p>
@@ -18370,7 +18370,7 @@
               <a:buNone/>
             </a:pPr>
             <a:r>
-              <a:rPr lang="en-US" sz="1300" dirty="0">
+              <a:rPr lang="en-US" sz="1200" dirty="0">
                 <a:solidFill>
                   <a:srgbClr val="7A7A7A"/>
                 </a:solidFill>
@@ -18378,9 +18378,9 @@
                 <a:ea typeface="나눔스퀘어 네오 Regular" pitchFamily="34" charset="-122"/>
                 <a:cs typeface="나눔스퀘어 네오 Regular" pitchFamily="34" charset="-120"/>
               </a:rPr>
-              <a:t>Genus 합성, 5 ns, GPDK045. 입력 4096가지(256각도) 기준, RMCM은 직접 행렬곱과 bit-exact. 1024각도에서는 RMCM 19,071 µm²·0.297 mW·+1,178 ps, 직접 행렬곱 5,209 µm²·0.279 mW·0 ps.</a:t>
+              <a:t>Genus 합성, 5 ns, GPDK045. 입력 4096가지(256각도) 기준, RMCM은 직접 행렬곱과 bit-exact. 1024각도: 합성 RMCM 19,071 vs 직접 5,209 µm². P&amp;R(5 ns) RMCM 33,935 µm²·DRC 1만+·setup −20.9 ns, 직접 7,354 µm²·DRC 0·setup −0.099 ns.</a:t>
             </a:r>
-            <a:endParaRPr lang="en-US" sz="1300" dirty="0"/>
+            <a:endParaRPr lang="en-US" sz="1200" dirty="0"/>
           </a:p>
         </p:txBody>
       </p:sp>
@@ -18444,7 +18444,7 @@
                 <a:ea typeface="나눔스퀘어 네오 Bold" pitchFamily="34" charset="-122"/>
                 <a:cs typeface="나눔스퀘어 네오 Bold" pitchFamily="34" charset="-120"/>
               </a:rPr>
-              <a:t>곱셈기를 없애는 것이 항상 이득은 아니다. 256각도(입력 4,096가지)에서는 표가 이겼지만, 1024각도(16,384가지)에서는 표가 직접 행렬곱보다 3.7배 커서 결과가 뒤집혔다.</a:t>
+              <a:t>곱셈기를 없애는 것이 항상 이득은 아니다. 256각도(입력 4,096가지)에서는 표가 이겼지만, 1024각도(16,384가지)에서는 표가 직접 행렬곱보다 합성 3.7배, 배치배선 후 4.6배 크고 배선도 안 풀려 결과가 뒤집혔다.</a:t>
             </a:r>
             <a:endParaRPr lang="en-US" sz="1600" dirty="0"/>
           </a:p>

</xml_diff>